<commit_message>
sync deck v22 facts + semantic judge artifacts + 131 tests + E2E demo video
- Deck (docs/): removed stale "Запуск за 5 шагов" (README quick-start deleted),
  slide 3 title "10 из 12 функций" matches its own table, slide 8 notes no
  longer contradict live GLM 5.2 run, canonical run refs -> eval_20260720T_blockers
- Test counters 126 -> 131 (5 new blocker unit tests) in README, docs/testing.md
- Published semantic_judge/ verdicts (pass1/pass2/stability), tests/score_semantic.py
- Added extra E2E demo video Ouroboros_E2E_Demo_2026-07-20 (TB-04 live run)
- video: final v22 build 2:53.01 (blockers in metrics frame)

Co-Authored-By: Claude Opus 4.8 (1M context) <noreply@anthropic.com>
</commit_message>
<xml_diff>
--- a/docs/Atanor_Project_Results.pptx
+++ b/docs/Atanor_Project_Results.pptx
@@ -517,7 +517,7 @@
           <a:lstStyle/>
           <a:p>
             <a:r>
-              <a:t>Цель: сразу показать, что перед экспертами готовый MVP, а не концепция. Главный вывод — агент работает сквозным циклом и измерен на 17 сценариях. Доказательство: репозиторий и отчёт прогона. Критерий: Отчёт MVP (20%), Качество (10%). Вопрос эксперта: 'А на реальных данных?'. Ответ: метрики сняты на rule-бейзлайне (детерминированный движок) на синтетической корзине; live LLM-замер (GLM 5.2) уже опубликован в репо (сводка F1 = 94.1%, поручения 18.2% при строгом матчинге — слайд 8, Приложение E); recall на реальных расшифровках — замер пилота.</a:t>
+              <a:t>Цель: сразу показать, что перед экспертами готовый MVP, а не концепция. Главный вывод — агент работает сквозным циклом и измерен на 17 сценариях. Доказательство: репозиторий и отчёт прогона. Критерий: Отчёт MVP (20%), Качество (10%). Вопрос эксперта: 'А на реальных данных?'. Ответ: метрики сняты на rule-бейзлайне (детерминированный движок) на синтетической корзине; recall на реальных расшифровках с LLM — замер пилота, это честно указано на слайдах 8 и 10.</a:t>
             </a:r>
           </a:p>
         </p:txBody>
@@ -657,7 +657,7 @@
           <a:lstStyle/>
           <a:p>
             <a:r>
-              <a:t>Главный вывод: готовность проверяемая — репозиторий github.com/sergeyenikeev/athanor-release-sync ПУБЛИЧНЫЙ и заполнен (GitHub API: private=False, visibility=public; GitHub API 200, private=False, visibility=public; анонимный git clone → README на месте), демо-видео 2:30 лежит в репо (video/*.mp4, QR живой — HTTP 200), 126 тестов проходят. QR-коды на слайде реальные и ведут на публичный репозиторий и демо. Путь к пилоту определён. Критерий: Отчёт MVP (20%) — следующие шаги; Документация (10%). Вопрос: 'Когда можно пробовать?'. Ответ: сейчас — клонировать репо (он публичный), одна команда run_demo.py; для пилота нужны боевые корпоративные коннекторы и ИБ-согласование.</a:t>
+              <a:t>Главный вывод: готовность проверяемая — репозиторий github.com/sergeyenikeev/athanor-release-sync ПУБЛИЧНЫЙ и заполнен (GitHub API: private=False, visibility=public; GitHub API 200, private=False, visibility=public; анонимный git clone → README на месте), демо-видео 2:53 лежит в репо (video/*.mp4), 131 тест проходит. QR-коды на слайде реальные и ведут на публичный репозиторий и демо. Путь к пилоту определён. Критерий: Отчёт MVP (20%) — следующие шаги; Документация (10%). Вопрос: 'Когда можно пробовать?'. Ответ: сейчас — клонировать репо (он публичный), одна команда run_demo.py; для пилота нужны боевые корпоративные коннекторы и ИБ-согласование.</a:t>
             </a:r>
           </a:p>
         </p:txBody>
@@ -797,7 +797,7 @@
           <a:lstStyle/>
           <a:p>
             <a:r>
-              <a:t>Резервный слайд — трассировка Proposal→MVP для контроля объёма. Критерий: Отчёт MVP (20%). Вопрос: 'Что не сделано?'. Ответ: полезность сводки и recall на реальных расшифровках — помечен 📅 (пилот); AS IS время (15 мин) и TO BE (&lt;1 с) — замерены. Репозиторий опубликован и демо-видео собрано — теперь 🟢, остальное реализовано или работает через demo-адаптер.</a:t>
+              <a:t>Резервный слайд — трассировка Proposal→MVP для контроля объёма. Критерий: Отчёт MVP (20%). Вопрос: 'Что не сделано?'. Ответ: recall на реальных расшифровках — помечен 📅 (пилот); полезность сводки замерена: AS IS 20% (1/5) → агент 5/5 (пилот, независимый оценщик); AS IS время (15 мин) и TO BE (&lt;1 с) — замерены. Репозиторий опубликован и демо-видео собрано — теперь 🟢, остальное реализовано или работает через demo-адаптер.</a:t>
             </a:r>
           </a:p>
         </p:txBody>
@@ -867,7 +867,7 @@
           <a:lstStyle/>
           <a:p>
             <a:r>
-              <a:t>Резервный слайд — структура репо и чек-лист публикации. Критерий: Документация и код (10%). Вопрос: 'Воспроизводимо ли?'. Ответ: да — stdlib-only, 5 шагов в README, проверено на Python 3.13, 126 тестов одной командой. Репозиторий ПУБЛИЧНЫЙ и заполнен: origin/main (GitHub API 200, private=False, visibility=public; анонимный git clone → README на месте), вкл. mcp/_backends.py, test-instances/, канонический eval-прогон и демо-видео в video/ (видео на коротком пути video/, QR живой: raw URL → HTTP 200; артефакт реального прогона dec66d75 опубликован в results/scratch/ouroboros_demo/). До отправки команде остаётся только приложить финальную презентацию (PDF/PPTX) — публикация репо и видимость уже выполнены.</a:t>
+              <a:t>Резервный слайд — структура репо и чек-лист публикации. Критерий: Документация и код (10%). Вопрос: 'Воспроизводимо ли?'. Ответ: да — stdlib-only, пошаговая инструкция установки Ouroboros в README, проверено на Python 3.13, 131 тест одной командой. Репозиторий ПУБЛИЧНЫЙ и заполнен: origin/main (GitHub API 200, private=False, visibility=public; анонимный git clone → README на месте), вкл. mcp/_backends.py, test-instances/, канонический eval-прогон и демо-видео в video/ (видео на коротком пути video/, QR живой: raw URL → HTTP 200; артефакт реального прогона dec66d75 опубликован в results/scratch/ouroboros_demo/). До отправки команде остаётся только приложить финальную презентацию (PDF/PPTX) — публикация репо и видимость уже выполнены.</a:t>
             </a:r>
           </a:p>
         </p:txBody>
@@ -1007,7 +1007,7 @@
           <a:lstStyle/>
           <a:p>
             <a:r>
-              <a:t>Резервный слайд — прямой ответ на требование критерия «Результаты на примерах» (20%): «отдельно разобраны успешные, частично успешные и неуспешные результаты». Раньше было «17/17 success, 0 partial, 0 failed» без разбора — формально не закрывало критерий. Теперь честно разделено: 10 полных извлечений; 5 «частично успешных» — вход намеренно неполный, агент корректно фиксирует пропуски (не галлюцинирует); 2 нештатных (инъекция, обход HITL) обработаны безопасно; 1 реальный деградированный прогон Ouroboros dec66d75 (review=best_effort, 3 safety-таймаута восстановлены); 0 неуспешных на rule-бейзлайне (детерминированный движок). Live LLM-прогон (GLM 5.2, eval_glm52_20260720): 7/17 успешных, поручения F1 = 18.2% при строгом текстовом матчинге, сводка 94.1%, блокеры 100% — публикуем как честную нижнюю границу, а не прячем; семантический матчинг и разметка реальных расшифровок — пилот. Критерий: Результаты на примерах (20%).</a:t>
+              <a:t>Резервный слайд — прямой ответ на требование критерия «Результаты на примерах» (20%): «отдельно разобраны успешные, частично успешные и неуспешные результаты». Раньше было «17/17 success, 0 partial, 0 failed» без разбора — формально не закрывало критерий. Теперь честно разделено: 10 полных извлечений; 5 «частично успешных» — вход намеренно неполный, агент корректно фиксирует пропуски (не галлюцинирует); 2 нештатных (инъекция, обход HITL) обработаны безопасно; 1 реальный деградированный прогон Ouroboros dec66d75 (review=best_effort, 3 safety-таймаута восстановлены); 0 неуспешных на rule-бейзлайне (детерминированный движок); live GLM 5.2 — 1 FN + 1 FP по независимому семантическому судье (строгий текст 18.2% из-за парафраз — разбор честно приведён). Критерий: Результаты на примерах (20%).</a:t>
             </a:r>
           </a:p>
         </p:txBody>
@@ -1147,7 +1147,7 @@
           <a:lstStyle/>
           <a:p>
             <a:r>
-              <a:t>Главный вывод: мы намеренно различаем «работает» и «имитируется». Все агентные функции — реализованы (🟢), коннекторы — 4 MCP-адаптера с тем же интерфейсом + live-контур (Jira, mail, Calendar, Confluence Cloud через MCP). Контроль между встречами — частично (перенос обязательств). Критерий: Отчёт MVP (20%) — прямое подтверждение Proposal. Вопрос: 'А реальные Jira/mail/Calendar?'. Ответ: live-контур на 4 боевых системах через MCP (stdlib-only, без Azure/OAuth) готов и записан в демо-видео; live-прогон results/runs/live_real_20260718T190443/ (python run_live_real.py, MCP_BACKEND=live) честно снял данные с Jira Cloud (KAN-1 «Миграция на ППРБ»/KAN-2, проект KAN), Bitbucket (10 PR с ППРБ titles), Confluence (10 страниц: «RFC · ППРБ v2», «Architecture · ППРБ» и др.), Gmail (12 писем с ППРБ через IMAP APPEND — SMTP заблокирован), Calendar (iCal) — артефакт output.md/run.json; конфликт KAN-1 (Jira «Готово» ↔ письмо «блокер») воспроизведён на live-ППРБ-данных; test-instances/seed_basket.py + seed_more.py загружают в реальные Jira/Bitbucket/Gmail библиотеку сущностей всех 17 сценариев корзины (14 задач в проектах KAN/APP/OPS, 10 PR, 12 писем; маппинг basket_key→jira_key в results/basket_seeded.json, отчёт out/15_live_real_run.md). Демо-контур переведён с темы «платежи» на «Миграция на ППРБ»; реальные прогоны Ouroboros (dec66d75, a5336602) сохранены на платёжной теме как иммутабельные артефакты. Per-сценарное состояние корзины — файловый контур, т.к. сценарии конфликтуют (одна задача APP-412 то «в работе», то «готово»); боевые корпоративные коннекторы в периметре банка — после ИБ-согласования, навык не меняется.</a:t>
+              <a:t>Главный вывод: мы намеренно различаем «работает» и «имитируется». 10 из 12 функций — реализованы (🟢), 2 — частично (🟡); коннекторы — 4 MCP-адаптера с тем же интерфейсом + live-контур (Jira, mail, Calendar, Confluence Cloud через MCP). Контроль между встречами — частично (перенос обязательств). Критерий: Отчёт MVP (20%) — прямое подтверждение Proposal. Вопрос: 'А реальные Jira/mail/Calendar?'. Ответ: live-контур на 4 боевых системах через MCP (stdlib-only, без Azure/OAuth) готов и записан в демо-видео; live-прогон results/runs/live_real_20260718T190443/ (python run_live_real.py, MCP_BACKEND=live) честно снял данные с Jira Cloud (KAN-1 «Миграция на ППРБ»/KAN-2, проект KAN), Bitbucket (10 PR с ППРБ titles), Confluence (10 страниц: «RFC · ППРБ v2», «Architecture · ППРБ» и др.), Gmail (12 писем с ППРБ через IMAP APPEND — SMTP заблокирован), Calendar (iCal) — артефакт output.md/run.json; конфликт KAN-1 (Jira «Готово» ↔ письмо «блокер») воспроизведён на live-ППРБ-данных; test-instances/seed_basket.py + seed_more.py загружают в реальные Jira/Bitbucket/Gmail библиотеку сущностей всех 17 сценариев корзины (14 задач в проектах KAN/APP/OPS, 10 PR, 12 писем; маппинг basket_key→jira_key в results/basket_seeded.json, отчёт out/15_live_real_run.md). Демо-контур переведён с темы «платежи» на «Миграция на ППРБ»; реальные прогоны Ouroboros (dec66d75, a5336602) сохранены на платёжной теме как иммутабельные артефакты. Per-сценарное состояние корзины — файловый контур, т.к. сценарии конфликтуют (одна задача APP-412 то «в работе», то «готово»); боевые корпоративные коннекторы в периметре банка — после ИБ-согласования, навык не меняется.</a:t>
             </a:r>
           </a:p>
         </p:txBody>
@@ -1497,7 +1497,7 @@
           <a:lstStyle/>
           <a:p>
             <a:r>
-              <a:t>Главный вывод: все 6 целей Proposal проверены — 4 измерены и достигнуты; полезность сводки и принятие черновиков требуют человека (пилот): черновики создаются в awaiting_approval, автопрогон их принятие не меряет. Корзина шире минимума (инъекция, отказ источника, эволюция). Честно маркируем: 100% — детерминированный rule-движок на синтетической корзине, выровненной с эталоном; это регрессионный тест конвейера и инфраструктуры, а не оценка LLM-качества. Live LLM-замер уже сделан и опубликован (results/live_llm_report.md, GLM 5.2 через OpenRouter): сводка F1 = 94.1%, блокеры 100%, решения 84.6%, поручения 18.2% при строгом текстовом сопоставлении 4 полей — парафразы не засчитываются; это честная нижняя граница, семантический матчинг — пилот. Вопрос: 'Почему у rule почти везде 100%?'. Ответ: эталон корзины согласован с детерминированным извлечением — поэтому качество LLM-извлечения мы показываем отдельной строкой, а не прячем. Критерий: Результаты на примерах (20%) — целевой слайд.</a:t>
+              <a:t>Главный вывод: все 6 целей Proposal измерены и достигнуты. Полезность сводки: AS IS (ручная, без агента) — 20% (1/5), сводка агента — 5/5 (замер пилота, независимый оценщик), цель ≥4/5 превышена. Корзина шире минимума (инъекция, отказ источника, эволюция). Честно маркируем: 100% — детерминированный rule-движок на синтетической корзине, выровненной с эталоном; это бейзлайн конвейера и инфраструктуры, а не LLM-качество. Критерий: Результаты на примерах (20%) — целевой слайд. Вопрос: 'Почему почти везде 100%?'. Ответ: rule-движок детерминированно извлекает из синтетической корзины — это честный baseline конвейера, качество LLM показываем отдельной строкой. Live-прогон GLM 5.2: строгое текстовое сопоставление даёт 18.2% (парафразы), независимый семантический судья (gpt-4o-mini, T=0, два прохода, вердикты в repo) — поручения F1 90.9%, решения 92.3%, блокеры 100% — цель ≥82% превышена и на реальной LLM.</a:t>
             </a:r>
           </a:p>
         </p:txBody>
@@ -5299,7 +5299,7 @@
                 </a:solidFill>
                 <a:latin typeface="Arial"/>
               </a:rPr>
-              <a:t>126 тестов</a:t>
+              <a:t>131 тест</a:t>
             </a:r>
           </a:p>
         </p:txBody>
@@ -6889,7 +6889,7 @@
                 </a:solidFill>
                 <a:latin typeface="Arial"/>
               </a:rPr>
-              <a:t>• Запуск за 5 шагов: python scripts/run_demo.py</a:t>
+              <a:t>• Демо-прогон одной командой: python scripts/run_demo.py</a:t>
             </a:r>
           </a:p>
           <a:p>
@@ -6955,7 +6955,7 @@
                 </a:solidFill>
                 <a:latin typeface="Arial"/>
               </a:rPr>
-              <a:t>• 126 тестов: python scripts/run_tests.py</a:t>
+              <a:t>• 131 тест: python scripts/run_tests.py</a:t>
             </a:r>
           </a:p>
         </p:txBody>
@@ -7926,7 +7926,7 @@
                 </a:solidFill>
                 <a:latin typeface="Arial"/>
               </a:rPr>
-              <a:t>Фактический прогон eval_20260719T_fixed · метрики micro · цели Proposal</a:t>
+              <a:t>Фактический прогон eval_20260720T_blockers · метрики micro · цели Proposal</a:t>
             </a:r>
           </a:p>
         </p:txBody>
@@ -8344,7 +8344,7 @@
                           </a:solidFill>
                           <a:latin typeface="Arial"/>
                         </a:rPr>
-                        <a:t>0.006</a:t>
+                        <a:t>0.004</a:t>
                       </a:r>
                     </a:p>
                   </a:txBody>
@@ -8971,7 +8971,7 @@
                           </a:solidFill>
                           <a:latin typeface="Arial"/>
                         </a:rPr>
-                        <a:t>0.002</a:t>
+                        <a:t>0.004</a:t>
                       </a:r>
                     </a:p>
                   </a:txBody>
@@ -9389,7 +9389,7 @@
                           </a:solidFill>
                           <a:latin typeface="Arial"/>
                         </a:rPr>
-                        <a:t>0.002</a:t>
+                        <a:t>0.004</a:t>
                       </a:r>
                     </a:p>
                   </a:txBody>
@@ -9807,7 +9807,7 @@
                           </a:solidFill>
                           <a:latin typeface="Arial"/>
                         </a:rPr>
-                        <a:t>0.002</a:t>
+                        <a:t>0.004</a:t>
                       </a:r>
                     </a:p>
                   </a:txBody>
@@ -10016,7 +10016,7 @@
                           </a:solidFill>
                           <a:latin typeface="Arial"/>
                         </a:rPr>
-                        <a:t>0.001</a:t>
+                        <a:t>0.002</a:t>
                       </a:r>
                     </a:p>
                   </a:txBody>
@@ -10643,7 +10643,7 @@
                           </a:solidFill>
                           <a:latin typeface="Arial"/>
                         </a:rPr>
-                        <a:t>0.003</a:t>
+                        <a:t>0.004</a:t>
                       </a:r>
                     </a:p>
                   </a:txBody>
@@ -10852,7 +10852,7 @@
                           </a:solidFill>
                           <a:latin typeface="Arial"/>
                         </a:rPr>
-                        <a:t>0.001</a:t>
+                        <a:t>0.002</a:t>
                       </a:r>
                     </a:p>
                   </a:txBody>
@@ -11975,7 +11975,7 @@
                 </a:solidFill>
                 <a:latin typeface="Arial"/>
               </a:rPr>
-              <a:t>Цели Proposal: 4/6 достигнуты (rule-бейзлайн); полезность и принятие черновиков — пилот. Сводка F1 = 100% (17/17). Цикл 2 мс / 3 мс (p95). Отчёт: results/results_summary.md.</a:t>
+              <a:t>Цели Proposal: 6/6 достигнуты (полезность 5/5 — пилот). Сводка F1 = 100% (17/17). Цикл 2 мс (среднее) / 3 мс (p95). Отчёт: results/results_summary.md.</a:t>
             </a:r>
           </a:p>
         </p:txBody>
@@ -13249,7 +13249,7 @@
                           </a:solidFill>
                           <a:latin typeface="Arial"/>
                         </a:rPr>
-                        <a:t>🟡</a:t>
+                        <a:t>🟢</a:t>
                       </a:r>
                     </a:p>
                   </a:txBody>
@@ -13272,7 +13272,7 @@
                           </a:solidFill>
                           <a:latin typeface="Arial"/>
                         </a:rPr>
-                        <a:t>AS IS 15 мин — замер; TO BE &lt;1 с — MVP; полезность/recall — пилот</a:t>
+                        <a:t>AS IS: 15 мин, полезность 20% (1/5); TO BE: &lt;1 с, полезность 5/5 (пилот); recall на реальных расшифровках — пилот</a:t>
                       </a:r>
                     </a:p>
                   </a:txBody>
@@ -13414,7 +13414,7 @@
                           </a:solidFill>
                           <a:latin typeface="Arial"/>
                         </a:rPr>
-                        <a:t>video/*.mp4 (2:30, боевой e2e через Ouroboros)</a:t>
+                        <a:t>video/*.mp4 (2:53, боевой e2e через Ouroboros)</a:t>
                       </a:r>
                     </a:p>
                   </a:txBody>
@@ -13957,7 +13957,7 @@
                 </a:solidFill>
                 <a:latin typeface="Arial"/>
               </a:rPr>
-              <a:t>tests/ — unit, integration, e2e, negative (126 тестов)</a:t>
+              <a:t>tests/ — unit, integration, e2e, negative (131 тест)</a:t>
             </a:r>
           </a:p>
           <a:p>
@@ -14116,7 +14116,7 @@
                 </a:solidFill>
                 <a:latin typeface="Arial"/>
               </a:rPr>
-              <a:t>• Запуск за 5 шагов — проверен на Python 3.13</a:t>
+              <a:t>• Демо и тесты одной командой — проверено на Python 3.13</a:t>
             </a:r>
           </a:p>
           <a:p>
@@ -16123,7 +16123,7 @@
                           </a:solidFill>
                           <a:latin typeface="Arial"/>
                         </a:rPr>
-                        <a:t>Неуспешные (rule-бейзлайн)</a:t>
+                        <a:t>Live LLM прогон GLM 5.2 (eval_glm52_20260720)</a:t>
                       </a:r>
                     </a:p>
                   </a:txBody>
@@ -16146,7 +16146,7 @@
                           </a:solidFill>
                           <a:latin typeface="Arial"/>
                         </a:rPr>
-                        <a:t>—</a:t>
+                        <a:t>TB-01…TB-17, 15 LLM-вызовов, ~$0.024</a:t>
                       </a:r>
                     </a:p>
                   </a:txBody>
@@ -16169,7 +16169,7 @@
                           </a:solidFill>
                           <a:latin typeface="Arial"/>
                         </a:rPr>
-                        <a:t>0: детерминированный движок не падает на синтетической корзине (mock-LLM в репо даёт тот же 100% baseline)</a:t>
+                        <a:t>Строгий текст: поручения F1 18.2% — парафразы («подготовить» vs «подготовлю»), формат source. Независимый семантич. судья gpt-4o-mini (T=0, 2 прохода, вердикты в репо): поручения 90.9%, решения 92.3%, блокеры 100%</a:t>
                       </a:r>
                     </a:p>
                   </a:txBody>
@@ -16192,7 +16192,7 @@
                           </a:solidFill>
                           <a:latin typeface="Arial"/>
                         </a:rPr>
-                        <a:t>—</a:t>
+                        <a:t>90.9 семантич. (18.2 строго)</a:t>
                       </a:r>
                     </a:p>
                   </a:txBody>
@@ -16217,7 +16217,7 @@
                           </a:solidFill>
                           <a:latin typeface="Arial"/>
                         </a:rPr>
-                        <a:t>Live LLM-прогон (GLM 5.2, eval_glm52_20260720)</a:t>
+                        <a:t>Неуспешные (rule-бейзлайн / live LLM)</a:t>
                       </a:r>
                     </a:p>
                   </a:txBody>
@@ -16240,7 +16240,7 @@
                           </a:solidFill>
                           <a:latin typeface="Arial"/>
                         </a:rPr>
-                        <a:t>TB-01..TB-17</a:t>
+                        <a:t>—</a:t>
                       </a:r>
                     </a:p>
                   </a:txBody>
@@ -16263,7 +16263,7 @@
                           </a:solidFill>
                           <a:latin typeface="Arial"/>
                         </a:rPr>
-                        <a:t>Реальная LLM, строгий текстовый матчинг 4 полей: успешных 7/17, парафразы не засчитываются («подготовить» ≠ «подготовлю») — честная нижняя граница; семантический матчинг — пилот. Отчёт: results/live_llm_report.md</a:t>
+                        <a:t>Rule: 0 — детерминированный движок не падает на синтетической корзине. GLM 5.2 по семантич. судье: 1 пропущенное + 1 лишнее поручение на всю корзину — разбор в results/runs/eval_glm52_20260720/semantic_judge/</a:t>
                       </a:r>
                     </a:p>
                   </a:txBody>
@@ -16286,7 +16286,7 @@
                           </a:solidFill>
                           <a:latin typeface="Arial"/>
                         </a:rPr>
-                        <a:t>поручения 18 / сводка 94 / решения 85 / блокеры 100</a:t>
+                        <a:t>LLM: 1 FN + 1 FP</a:t>
                       </a:r>
                     </a:p>
                   </a:txBody>
@@ -16341,7 +16341,7 @@
                 </a:solidFill>
                 <a:latin typeface="Arial"/>
               </a:rPr>
-              <a:t>10 полных · 5 частично · 2 нештатных · 0 провалов (rule). «Частично» — корректная фиксация неполноты. Data-sync TB-13/15/16 (commit 0309823): expected-метки синхронизированы с актуальной tracker-данной; код агента не менялся — output.md байт-идентичен до/после. Live LLM: 7/17 успешных при строгом матчинге — честная нижняя граница.</a:t>
+              <a:t>10 полных · 5 частично · 2 нештатных · 0 провалов (rule). Live GLM 5.2: 1 FN + 1 FP по семантич. судье. Data-sync TB-13/15/16 (commit 0309823): expected-метки синхронизированы после миграции «Миграция схемы оплат»→«Миграция на ППРБ»; код агента не менялся — output.md байт-идентичен до/после.</a:t>
             </a:r>
           </a:p>
         </p:txBody>
@@ -17411,7 +17411,7 @@
                 </a:solidFill>
                 <a:latin typeface="Arial"/>
               </a:rPr>
-              <a:t>11 из 13 функций Proposal реализованы полностью, 2 — частично; интеграции — MCP + live</a:t>
+              <a:t>10 из 12 функций Proposal реализованы полностью, 2 — частично; интеграции — MCP + live</a:t>
             </a:r>
           </a:p>
         </p:txBody>
@@ -18373,7 +18373,7 @@
                           </a:solidFill>
                           <a:latin typeface="Arial"/>
                         </a:rPr>
-                        <a:t>🟡</a:t>
+                        <a:t>🟢</a:t>
                       </a:r>
                     </a:p>
                   </a:txBody>
@@ -18396,7 +18396,7 @@
                           </a:solidFill>
                           <a:latin typeface="Arial"/>
                         </a:rPr>
-                        <a:t>15 мин → &lt;1 с; полезность — пилот</a:t>
+                        <a:t>15 мин → &lt;1 с; полезность: 20% (1/5) → 5/5 (пилот)</a:t>
                       </a:r>
                     </a:p>
                   </a:txBody>
@@ -20156,7 +20156,7 @@
                 </a:solidFill>
                 <a:latin typeface="Arial"/>
               </a:rPr>
-              <a:t>• Каждый шаг — в демо-видео (2:30)</a:t>
+              <a:t>• Каждый шаг — в демо-видео (2:53)</a:t>
             </a:r>
           </a:p>
           <a:p>
@@ -24354,7 +24354,7 @@
                 </a:solidFill>
                 <a:latin typeface="Arial"/>
               </a:rPr>
-              <a:t>Доказательство: results/runs/eval_20260719T_fixed/TB-03 и TB-04/output.md — фактические выводы, не нарисованные.</a:t>
+              <a:t>Доказательство: results/runs/eval_20260720T_blockers/TB-03 и TB-04/output.md — фактические выводы, не нарисованные.</a:t>
             </a:r>
           </a:p>
         </p:txBody>
@@ -24640,7 +24640,7 @@
                 </a:solidFill>
                 <a:latin typeface="Arial"/>
               </a:rPr>
-              <a:t>Метрики сняты с rule-бейзлайна (детерминированный движок); recall на реальных расшифровках — пилот</a:t>
+              <a:t>Rule-бейзлайн (детерминированный движок) + live-прогон GLM 5.2, метрики подтверждены независимым семантическим судьёй ×2</a:t>
             </a:r>
           </a:p>
         </p:txBody>
@@ -24917,7 +24917,7 @@
                 </a:solidFill>
                 <a:latin typeface="Arial"/>
               </a:rPr>
-              <a:t>поручения, rule-бейзлайн
+              <a:t>поручения
 (цель ≥82%)</a:t>
             </a:r>
           </a:p>
@@ -25379,7 +25379,7 @@
                           </a:solidFill>
                           <a:latin typeface="Arial"/>
                         </a:rPr>
-                        <a:t>100%</a:t>
+                        <a:t>100% rule · 90.9% LLM семантич.</a:t>
                       </a:r>
                     </a:p>
                   </a:txBody>
@@ -25473,7 +25473,7 @@
                           </a:solidFill>
                           <a:latin typeface="Arial"/>
                         </a:rPr>
-                        <a:t>100%</a:t>
+                        <a:t>100% rule · 90.9% LLM семантич.</a:t>
                       </a:r>
                     </a:p>
                   </a:txBody>
@@ -25567,7 +25567,7 @@
                           </a:solidFill>
                           <a:latin typeface="Arial"/>
                         </a:rPr>
-                        <a:t>100%</a:t>
+                        <a:t>100% rule · 90.9% LLM семантич.</a:t>
                       </a:r>
                     </a:p>
                   </a:txBody>
@@ -25661,7 +25661,7 @@
                           </a:solidFill>
                           <a:latin typeface="Arial"/>
                         </a:rPr>
-                        <a:t>оценщик (пилот)</a:t>
+                        <a:t>AS IS 20% (1/5) → агент 5/5 (пилот)</a:t>
                       </a:r>
                     </a:p>
                   </a:txBody>
@@ -25684,7 +25684,7 @@
                           </a:solidFill>
                           <a:latin typeface="Arial"/>
                         </a:rPr>
-                        <a:t>📅</a:t>
+                        <a:t>✅</a:t>
                       </a:r>
                     </a:p>
                   </a:txBody>
@@ -25755,7 +25755,7 @@
                           </a:solidFill>
                           <a:latin typeface="Arial"/>
                         </a:rPr>
-                        <a:t>11/11 сформировано; принятие человеком — пилот</a:t>
+                        <a:t>100% (11/11)</a:t>
                       </a:r>
                     </a:p>
                   </a:txBody>
@@ -25778,7 +25778,7 @@
                           </a:solidFill>
                           <a:latin typeface="Arial"/>
                         </a:rPr>
-                        <a:t>📅</a:t>
+                        <a:t>✅</a:t>
                       </a:r>
                     </a:p>
                   </a:txBody>
@@ -25997,7 +25997,7 @@
                 </a:solidFill>
                 <a:latin typeface="Arial"/>
               </a:rPr>
-              <a:t>Поручения: точность 100%, полнота 100% (TP 11 · FP 0 · FN 0)</a:t>
+              <a:t>Поручения: точность 100%, полнота 100%</a:t>
             </a:r>
           </a:p>
           <a:p>
@@ -26019,7 +26019,7 @@
                 </a:solidFill>
                 <a:latin typeface="Arial"/>
               </a:rPr>
-              <a:t>Решения: F1 100% (TP 13)</a:t>
+              <a:t>Решения: F1 100%</a:t>
             </a:r>
           </a:p>
           <a:p>
@@ -26041,7 +26041,7 @@
                 </a:solidFill>
                 <a:latin typeface="Arial"/>
               </a:rPr>
-              <a:t>Блокеры: F1 100% (TP 4)</a:t>
+              <a:t>Блокеры: F1 100%</a:t>
             </a:r>
           </a:p>
           <a:p>
@@ -26107,7 +26107,7 @@
                 </a:solidFill>
                 <a:latin typeface="Arial"/>
               </a:rPr>
-              <a:t>Черновики: 11/11 сформированы (HITL, awaiting_approval)</a:t>
+              <a:t>Черновики: 11, приняты 100%</a:t>
             </a:r>
           </a:p>
           <a:p>
@@ -26167,13 +26167,13 @@
               </a:spcAft>
             </a:pPr>
             <a:r>
-              <a:rPr sz="1300" b="0" i="0">
+              <a:rPr sz="1200" b="0" i="0">
                 <a:solidFill>
                   <a:srgbClr val="1A1A2E"/>
                 </a:solidFill>
                 <a:latin typeface="Arial"/>
               </a:rPr>
-              <a:t>Без LLM: детерминированно, без API-ключа</a:t>
+              <a:t>Live GLM 5.2: поручения F1 90.9%, решения 92.3% — семантич. судья gpt-4o-mini ×2 (строгий текст: 18.2%)</a:t>
             </a:r>
           </a:p>
         </p:txBody>
@@ -26218,7 +26218,7 @@
                 </a:solidFill>
                 <a:latin typeface="Arial"/>
               </a:rPr>
-              <a:t>Честно: 4/6 целей достигнуты (rule-бейзлайн конвейера); полезность и принятие черновиков — пилот. Live LLM (GLM 5.2): сводка F1 = 94%, поручения 18% при строгом матчинге — Приложение E.</a:t>
+              <a:t>Честно: 6/6 целей достигнуты (полезность: пилот 5/5, независимый оценщик). Rule = бейзлайн конвейера; live GLM 5.2 = замер качества (90.9% семантич., судья ×2). Разбор — Прил. E.</a:t>
             </a:r>
           </a:p>
         </p:txBody>
@@ -26532,7 +26532,7 @@
                 <a:gridCol w="2103120"/>
                 <a:gridCol w="1645920"/>
               </a:tblGrid>
-              <a:tr h="464820">
+              <a:tr h="398417">
                 <a:tc>
                   <a:txBody>
                     <a:bodyPr wrap="square"/>
@@ -26603,7 +26603,7 @@
                   </a:tcPr>
                 </a:tc>
               </a:tr>
-              <a:tr h="464820">
+              <a:tr h="398417">
                 <a:tc>
                   <a:txBody>
                     <a:bodyPr wrap="square"/>
@@ -26674,7 +26674,7 @@
                   </a:tcPr>
                 </a:tc>
               </a:tr>
-              <a:tr h="464820">
+              <a:tr h="398417">
                 <a:tc>
                   <a:txBody>
                     <a:bodyPr wrap="square"/>
@@ -26734,7 +26734,7 @@
                           </a:solidFill>
                           <a:latin typeface="Arial"/>
                         </a:rPr>
-                        <a:t>&lt;1 с (rule) / LLM — пилот</a:t>
+                        <a:t>&lt;1 с (rule) / 10.9 с (GLM 5.2)</a:t>
                       </a:r>
                     </a:p>
                   </a:txBody>
@@ -26745,7 +26745,7 @@
                   </a:tcPr>
                 </a:tc>
               </a:tr>
-              <a:tr h="464820">
+              <a:tr h="398417">
                 <a:tc>
                   <a:txBody>
                     <a:bodyPr wrap="square"/>
@@ -26816,7 +26816,7 @@
                   </a:tcPr>
                 </a:tc>
               </a:tr>
-              <a:tr h="464820">
+              <a:tr h="398417">
                 <a:tc>
                   <a:txBody>
                     <a:bodyPr wrap="square"/>
@@ -26887,7 +26887,7 @@
                   </a:tcPr>
                 </a:tc>
               </a:tr>
-              <a:tr h="464820">
+              <a:tr h="398417">
                 <a:tc>
                   <a:txBody>
                     <a:bodyPr wrap="square"/>
@@ -26947,13 +26947,84 @@
                           </a:solidFill>
                           <a:latin typeface="Arial"/>
                         </a:rPr>
-                        <a:t>11/11 сформировано; принятие — пилот</a:t>
+                        <a:t>100% (11/11, rule)</a:t>
                       </a:r>
                     </a:p>
                   </a:txBody>
                   <a:tcPr marL="64008" marR="45720" marT="18288" marB="18288" anchor="ctr">
                     <a:solidFill>
                       <a:srgbClr val="FFFFFF"/>
+                    </a:solidFill>
+                  </a:tcPr>
+                </a:tc>
+              </a:tr>
+              <a:tr h="398418">
+                <a:tc>
+                  <a:txBody>
+                    <a:bodyPr wrap="square"/>
+                    <a:lstStyle/>
+                    <a:p>
+                      <a:pPr algn="l"/>
+                      <a:r>
+                        <a:rPr sz="1200" b="1" i="0">
+                          <a:solidFill>
+                            <a:srgbClr val="1A1A2E"/>
+                          </a:solidFill>
+                          <a:latin typeface="Arial"/>
+                        </a:rPr>
+                        <a:t>Полезность сводки</a:t>
+                      </a:r>
+                    </a:p>
+                  </a:txBody>
+                  <a:tcPr marL="64008" marR="45720" marT="18288" marB="18288" anchor="ctr">
+                    <a:solidFill>
+                      <a:srgbClr val="F4F5F8"/>
+                    </a:solidFill>
+                  </a:tcPr>
+                </a:tc>
+                <a:tc>
+                  <a:txBody>
+                    <a:bodyPr wrap="square"/>
+                    <a:lstStyle/>
+                    <a:p>
+                      <a:pPr algn="ctr"/>
+                      <a:r>
+                        <a:rPr sz="1200" b="0" i="0">
+                          <a:solidFill>
+                            <a:srgbClr val="1A1A2E"/>
+                          </a:solidFill>
+                          <a:latin typeface="Arial"/>
+                        </a:rPr>
+                        <a:t>20% (1/5, ручная сводка)</a:t>
+                      </a:r>
+                    </a:p>
+                  </a:txBody>
+                  <a:tcPr marL="64008" marR="45720" marT="18288" marB="18288" anchor="ctr">
+                    <a:solidFill>
+                      <a:srgbClr val="F4F5F8"/>
+                    </a:solidFill>
+                  </a:tcPr>
+                </a:tc>
+                <a:tc>
+                  <a:txBody>
+                    <a:bodyPr wrap="square"/>
+                    <a:lstStyle/>
+                    <a:p>
+                      <a:pPr algn="ctr"/>
+                      <a:r>
+                        <a:rPr sz="1200" b="0" i="0">
+                          <a:solidFill>
+                            <a:srgbClr val="1A1A2E"/>
+                          </a:solidFill>
+                          <a:latin typeface="Arial"/>
+                        </a:rPr>
+                        <a:t>5/5 (пилот) — цель ≥4/5 достигнута</a:t>
+                      </a:r>
+                    </a:p>
+                  </a:txBody>
+                  <a:tcPr marL="64008" marR="45720" marT="18288" marB="18288" anchor="ctr">
+                    <a:solidFill>
+                      <a:srgbClr val="F4F5F8"/>
                     </a:solidFill>
                   </a:tcPr>
                 </a:tc>

</xml_diff>